<commit_message>
web sync 2026-10-05 1519
</commit_message>
<xml_diff>
--- a/SIC_색상스키마.pptx
+++ b/SIC_색상스키마.pptx
@@ -8,9 +8,10 @@
     <p:sldId id="256" r:id="rId2"/>
     <p:sldId id="257" r:id="rId3"/>
     <p:sldId id="258" r:id="rId4"/>
+    <p:sldId id="259" r:id="rId5"/>
   </p:sldIdLst>
   <p:notesMasterIdLst>
-    <p:notesMasterId r:id="rId5"/>
+    <p:notesMasterId r:id="rId6"/>
   </p:notesMasterIdLst>
   <p:sldSz cx="12192000" cy="6858000"/>
   <p:notesSz cx="6858000" cy="12192000"/>
@@ -109,11 +110,12 @@
   <p:extLst>
     <p:ext uri="{521415D9-36F7-43E2-AB2F-B90AF26B5E84}">
       <p14:sectionLst xmlns:p14="http://schemas.microsoft.com/office/powerpoint/2010/main">
-        <p14:section name="SIC 색상" id="{71b95308-12cd-3e01-90e9-fdedbf31b1f3}">
+        <p14:section name="SIC 색상" id="{12c3abbc-139d-a406-915e-01f4fb85ec2d}">
           <p14:sldIdLst>
             <p14:sldId id="256"/>
             <p14:sldId id="257"/>
             <p14:sldId id="258"/>
+            <p14:sldId id="259"/>
           </p14:sldIdLst>
         </p14:section>
       </p14:sectionLst>
@@ -720,6 +722,94 @@
             <a:fld id="{F7021451-1387-4CA6-816F-3879F97B5CBC}" type="slidenum">
               <a:rPr lang="en-US"/>
               <a:t>3</a:t>
+            </a:fld>
+            <a:endParaRPr lang="en-US"/>
+          </a:p>
+        </p:txBody>
+      </p:sp>
+    </p:spTree>
+    <p:extLst>
+      <p:ext uri="{BB962C8B-B14F-4D97-AF65-F5344CB8AC3E}">
+        <p14:creationId xmlns:p14="http://schemas.microsoft.com/office/powerpoint/2010/main" val="1024086991"/>
+      </p:ext>
+    </p:extLst>
+  </p:cSld>
+  <p:clrMapOvr>
+    <a:masterClrMapping/>
+  </p:clrMapOvr>
+</p:notes>
+</file>
+
+<file path=ppt/notesSlides/notesSlide4.xml><?xml version="1.0" encoding="utf-8"?>
+<p:notes xmlns:a="http://schemas.openxmlformats.org/drawingml/2006/main" xmlns:r="http://schemas.openxmlformats.org/officeDocument/2006/relationships" xmlns:p="http://schemas.openxmlformats.org/presentationml/2006/main">
+  <p:cSld>
+    <p:spTree>
+      <p:nvGrpSpPr>
+        <p:cNvPr id="1" name=""/>
+        <p:cNvGrpSpPr/>
+        <p:nvPr/>
+      </p:nvGrpSpPr>
+      <p:grpSpPr>
+        <a:xfrm>
+          <a:off x="0" y="0"/>
+          <a:ext cx="0" cy="0"/>
+          <a:chOff x="0" y="0"/>
+          <a:chExt cx="0" cy="0"/>
+        </a:xfrm>
+      </p:grpSpPr>
+      <p:sp>
+        <p:nvSpPr>
+          <p:cNvPr id="2" name="Slide Image Placeholder 1"/>
+          <p:cNvSpPr>
+            <a:spLocks noGrp="1" noRot="1" noChangeAspect="1"/>
+          </p:cNvSpPr>
+          <p:nvPr>
+            <p:ph type="sldImg"/>
+          </p:nvPr>
+        </p:nvSpPr>
+        <p:spPr/>
+      </p:sp>
+      <p:sp>
+        <p:nvSpPr>
+          <p:cNvPr id="3" name="Notes Placeholder 2"/>
+          <p:cNvSpPr>
+            <a:spLocks noGrp="1"/>
+          </p:cNvSpPr>
+          <p:nvPr>
+            <p:ph type="body" idx="1"/>
+          </p:nvPr>
+        </p:nvSpPr>
+        <p:spPr/>
+        <p:txBody>
+          <a:bodyPr/>
+          <a:lstStyle/>
+          <a:p>
+            <a:r>
+              <a:rPr lang="en-US" dirty="0"/>
+              <a:t/>
+            </a:r>
+            <a:endParaRPr lang="en-US" dirty="0"/>
+          </a:p>
+        </p:txBody>
+      </p:sp>
+      <p:sp>
+        <p:nvSpPr>
+          <p:cNvPr id="4" name="Slide Number Placeholder 3"/>
+          <p:cNvSpPr>
+            <a:spLocks noGrp="1"/>
+          </p:cNvSpPr>
+          <p:nvPr>
+            <p:ph type="sldNum" sz="quarter" idx="10"/>
+          </p:nvPr>
+        </p:nvSpPr>
+        <p:spPr/>
+        <p:txBody>
+          <a:bodyPr/>
+          <a:lstStyle/>
+          <a:p>
+            <a:fld id="{F7021451-1387-4CA6-816F-3879F97B5CBC}" type="slidenum">
+              <a:rPr lang="en-US"/>
+              <a:t>4</a:t>
             </a:fld>
             <a:endParaRPr lang="en-US"/>
           </a:p>
@@ -2880,6 +2970,984 @@
             <a:fld id="{F7021451-1387-4CA6-816F-3879F97B5CBC}" type="slidenum">
               <a:rPr b="0" lang="en-US"/>
               <a:t>3</a:t>
+            </a:fld>
+            <a:endParaRPr lang="en-US"/>
+          </a:p>
+        </p:txBody>
+      </p:sp>
+    </p:spTree>
+  </p:cSld>
+  <p:clrMapOvr>
+    <a:masterClrMapping/>
+  </p:clrMapOvr>
+</p:sld>
+</file>
+
+<file path=ppt/slides/slide4.xml><?xml version="1.0" encoding="utf-8"?>
+<p:sld xmlns:a="http://schemas.openxmlformats.org/drawingml/2006/main" xmlns:r="http://schemas.openxmlformats.org/officeDocument/2006/relationships" xmlns:p="http://schemas.openxmlformats.org/presentationml/2006/main">
+  <p:cSld name="Slide 4">
+    <p:spTree>
+      <p:nvGrpSpPr>
+        <p:cNvPr id="1" name=""/>
+        <p:cNvGrpSpPr/>
+        <p:nvPr/>
+      </p:nvGrpSpPr>
+      <p:grpSpPr>
+        <a:xfrm>
+          <a:off x="0" y="0"/>
+          <a:ext cx="0" cy="0"/>
+          <a:chOff x="0" y="0"/>
+          <a:chExt cx="0" cy="0"/>
+        </a:xfrm>
+      </p:grpSpPr>
+      <p:sp>
+        <p:nvSpPr>
+          <p:cNvPr id="2" name="Text 0"/>
+          <p:cNvSpPr/>
+          <p:nvPr>
+            <p:ph idx="100" type="title" hasCustomPrompt="1"/>
+          </p:nvPr>
+        </p:nvSpPr>
+        <p:spPr>
+          <a:xfrm>
+            <a:off x="502920" y="292608"/>
+            <a:ext cx="11155680" cy="685800"/>
+          </a:xfrm>
+          <a:prstGeom prst="rect">
+            <a:avLst/>
+          </a:prstGeom>
+          <a:noFill/>
+          <a:ln/>
+        </p:spPr>
+        <p:txBody>
+          <a:bodyPr wrap="square" lIns="0" tIns="0" rIns="0" bIns="0" rtlCol="0"/>
+          <a:lstStyle/>
+          <a:p>
+            <a:pPr indent="0" marL="0">
+              <a:buNone/>
+            </a:pPr>
+            <a:r>
+              <a:rPr lang="en-US" sz="2800" b="1" dirty="0">
+                <a:solidFill>
+                  <a:srgbClr val="0F2D52"/>
+                </a:solidFill>
+              </a:rPr>
+              <a:t>WMO 총빙량 옵션 — rainbow 와 선택 사용</a:t>
+            </a:r>
+            <a:endParaRPr lang="en-US" sz="2800" dirty="0"/>
+          </a:p>
+        </p:txBody>
+      </p:sp>
+      <p:sp>
+        <p:nvSpPr>
+          <p:cNvPr id="3" name="Text 1"/>
+          <p:cNvSpPr txBox="1"/>
+          <p:nvPr/>
+        </p:nvSpPr>
+        <p:spPr>
+          <a:xfrm>
+            <a:off x="502920" y="1024128"/>
+            <a:ext cx="7315200" cy="274320"/>
+          </a:xfrm>
+          <a:prstGeom prst="rect">
+            <a:avLst/>
+          </a:prstGeom>
+          <a:noFill/>
+          <a:ln/>
+        </p:spPr>
+        <p:txBody>
+          <a:bodyPr wrap="square" lIns="0" tIns="0" rIns="0" bIns="0" rtlCol="0" anchor="ctr"/>
+          <a:lstStyle/>
+          <a:p>
+            <a:pPr indent="0" marL="0">
+              <a:buNone/>
+            </a:pPr>
+            <a:r>
+              <a:rPr lang="en-US" sz="1150" dirty="0">
+                <a:solidFill>
+                  <a:srgbClr val="6B7B8C"/>
+                </a:solidFill>
+              </a:rPr>
+              <a:t>WMO/JCOMM Ice Chart Colour Code (WMO/TD-No.1215) 계급 — 범례에 계급 이름 표기</a:t>
+            </a:r>
+            <a:endParaRPr lang="en-US" sz="1150" dirty="0"/>
+          </a:p>
+        </p:txBody>
+      </p:sp>
+      <p:sp>
+        <p:nvSpPr>
+          <p:cNvPr id="4" name="Shape 2"/>
+          <p:cNvSpPr/>
+          <p:nvPr/>
+        </p:nvSpPr>
+        <p:spPr>
+          <a:xfrm>
+            <a:off x="502920" y="1371600"/>
+            <a:ext cx="502920" cy="329184"/>
+          </a:xfrm>
+          <a:prstGeom prst="rect">
+            <a:avLst/>
+          </a:prstGeom>
+          <a:solidFill>
+            <a:srgbClr val="081C6E"/>
+          </a:solidFill>
+          <a:ln w="9525">
+            <a:solidFill>
+              <a:srgbClr val="B9C4CE"/>
+            </a:solidFill>
+            <a:prstDash val="solid"/>
+          </a:ln>
+        </p:spPr>
+      </p:sp>
+      <p:sp>
+        <p:nvSpPr>
+          <p:cNvPr id="5" name="Text 3"/>
+          <p:cNvSpPr txBox="1"/>
+          <p:nvPr/>
+        </p:nvSpPr>
+        <p:spPr>
+          <a:xfrm>
+            <a:off x="1143000" y="1371600"/>
+            <a:ext cx="6400800" cy="329184"/>
+          </a:xfrm>
+          <a:prstGeom prst="rect">
+            <a:avLst/>
+          </a:prstGeom>
+          <a:noFill/>
+          <a:ln/>
+        </p:spPr>
+        <p:txBody>
+          <a:bodyPr wrap="square" lIns="0" tIns="0" rIns="0" bIns="0" rtlCol="0" anchor="ctr"/>
+          <a:lstStyle/>
+          <a:p>
+            <a:pPr indent="0" marL="0">
+              <a:buNone/>
+            </a:pPr>
+            <a:r>
+              <a:rPr lang="en-US" sz="1150" b="1" dirty="0">
+                <a:solidFill>
+                  <a:srgbClr val="0F2D52"/>
+                </a:solidFill>
+                <a:latin typeface="Courier New" pitchFamily="34" charset="0"/>
+                <a:ea typeface="Courier New" pitchFamily="34" charset="-122"/>
+                <a:cs typeface="Courier New" pitchFamily="34" charset="-120"/>
+              </a:rPr>
+              <a:t>0 ~ &lt;1 %    </a:t>
+            </a:r>
+            <a:pPr indent="0" marL="0">
+              <a:buNone/>
+            </a:pPr>
+            <a:r>
+              <a:rPr lang="en-US" sz="1150" dirty="0">
+                <a:solidFill>
+                  <a:srgbClr val="1A2733"/>
+                </a:solidFill>
+                <a:latin typeface="Courier New" pitchFamily="34" charset="0"/>
+                <a:ea typeface="Courier New" pitchFamily="34" charset="-122"/>
+                <a:cs typeface="Courier New" pitchFamily="34" charset="-120"/>
+              </a:rPr>
+              <a:t> #081c6e  </a:t>
+            </a:r>
+            <a:pPr indent="0" marL="0">
+              <a:buNone/>
+            </a:pPr>
+            <a:r>
+              <a:rPr lang="en-US" sz="1250" b="1" dirty="0">
+                <a:solidFill>
+                  <a:srgbClr val="1A2733"/>
+                </a:solidFill>
+              </a:rPr>
+              <a:t>Ice free (무빙)  </a:t>
+            </a:r>
+            <a:pPr indent="0" marL="0">
+              <a:buNone/>
+            </a:pPr>
+            <a:r>
+              <a:rPr lang="en-US" sz="1100" dirty="0">
+                <a:solidFill>
+                  <a:srgbClr val="6B7B8C"/>
+                </a:solidFill>
+              </a:rPr>
+              <a:t>rainbow 0% 남색과 통일 (표준 #0064ff 대체)</a:t>
+            </a:r>
+            <a:endParaRPr lang="en-US" sz="1150" dirty="0"/>
+          </a:p>
+        </p:txBody>
+      </p:sp>
+      <p:sp>
+        <p:nvSpPr>
+          <p:cNvPr id="6" name="Shape 4"/>
+          <p:cNvSpPr/>
+          <p:nvPr/>
+        </p:nvSpPr>
+        <p:spPr>
+          <a:xfrm>
+            <a:off x="502920" y="1801368"/>
+            <a:ext cx="502920" cy="329184"/>
+          </a:xfrm>
+          <a:prstGeom prst="rect">
+            <a:avLst/>
+          </a:prstGeom>
+          <a:solidFill>
+            <a:srgbClr val="96C8FF"/>
+          </a:solidFill>
+          <a:ln w="9525">
+            <a:solidFill>
+              <a:srgbClr val="B9C4CE"/>
+            </a:solidFill>
+            <a:prstDash val="solid"/>
+          </a:ln>
+        </p:spPr>
+      </p:sp>
+      <p:sp>
+        <p:nvSpPr>
+          <p:cNvPr id="7" name="Text 5"/>
+          <p:cNvSpPr txBox="1"/>
+          <p:nvPr/>
+        </p:nvSpPr>
+        <p:spPr>
+          <a:xfrm>
+            <a:off x="1143000" y="1801368"/>
+            <a:ext cx="6400800" cy="329184"/>
+          </a:xfrm>
+          <a:prstGeom prst="rect">
+            <a:avLst/>
+          </a:prstGeom>
+          <a:noFill/>
+          <a:ln/>
+        </p:spPr>
+        <p:txBody>
+          <a:bodyPr wrap="square" lIns="0" tIns="0" rIns="0" bIns="0" rtlCol="0" anchor="ctr"/>
+          <a:lstStyle/>
+          <a:p>
+            <a:pPr indent="0" marL="0">
+              <a:buNone/>
+            </a:pPr>
+            <a:r>
+              <a:rPr lang="en-US" sz="1150" b="1" dirty="0">
+                <a:solidFill>
+                  <a:srgbClr val="0F2D52"/>
+                </a:solidFill>
+                <a:latin typeface="Courier New" pitchFamily="34" charset="0"/>
+                <a:ea typeface="Courier New" pitchFamily="34" charset="-122"/>
+                <a:cs typeface="Courier New" pitchFamily="34" charset="-120"/>
+              </a:rPr>
+              <a:t>1 ~ &lt;10 %   </a:t>
+            </a:r>
+            <a:pPr indent="0" marL="0">
+              <a:buNone/>
+            </a:pPr>
+            <a:r>
+              <a:rPr lang="en-US" sz="1150" dirty="0">
+                <a:solidFill>
+                  <a:srgbClr val="1A2733"/>
+                </a:solidFill>
+                <a:latin typeface="Courier New" pitchFamily="34" charset="0"/>
+                <a:ea typeface="Courier New" pitchFamily="34" charset="-122"/>
+                <a:cs typeface="Courier New" pitchFamily="34" charset="-120"/>
+              </a:rPr>
+              <a:t> #96c8ff  </a:t>
+            </a:r>
+            <a:pPr indent="0" marL="0">
+              <a:buNone/>
+            </a:pPr>
+            <a:r>
+              <a:rPr lang="en-US" sz="1250" b="1" dirty="0">
+                <a:solidFill>
+                  <a:srgbClr val="1A2733"/>
+                </a:solidFill>
+              </a:rPr>
+              <a:t>개수면 &lt;1/10  </a:t>
+            </a:r>
+            <a:pPr indent="0" marL="0">
+              <a:buNone/>
+            </a:pPr>
+            <a:r>
+              <a:rPr lang="en-US" sz="1100" dirty="0">
+                <a:solidFill>
+                  <a:srgbClr val="6B7B8C"/>
+                </a:solidFill>
+              </a:rPr>
+              <a:t>Open water</a:t>
+            </a:r>
+            <a:endParaRPr lang="en-US" sz="1150" dirty="0"/>
+          </a:p>
+        </p:txBody>
+      </p:sp>
+      <p:sp>
+        <p:nvSpPr>
+          <p:cNvPr id="8" name="Shape 6"/>
+          <p:cNvSpPr/>
+          <p:nvPr/>
+        </p:nvSpPr>
+        <p:spPr>
+          <a:xfrm>
+            <a:off x="502920" y="2231136"/>
+            <a:ext cx="502920" cy="329184"/>
+          </a:xfrm>
+          <a:prstGeom prst="rect">
+            <a:avLst/>
+          </a:prstGeom>
+          <a:solidFill>
+            <a:srgbClr val="8CFFA0"/>
+          </a:solidFill>
+          <a:ln w="9525">
+            <a:solidFill>
+              <a:srgbClr val="B9C4CE"/>
+            </a:solidFill>
+            <a:prstDash val="solid"/>
+          </a:ln>
+        </p:spPr>
+      </p:sp>
+      <p:sp>
+        <p:nvSpPr>
+          <p:cNvPr id="9" name="Text 7"/>
+          <p:cNvSpPr txBox="1"/>
+          <p:nvPr/>
+        </p:nvSpPr>
+        <p:spPr>
+          <a:xfrm>
+            <a:off x="1143000" y="2231136"/>
+            <a:ext cx="6400800" cy="329184"/>
+          </a:xfrm>
+          <a:prstGeom prst="rect">
+            <a:avLst/>
+          </a:prstGeom>
+          <a:noFill/>
+          <a:ln/>
+        </p:spPr>
+        <p:txBody>
+          <a:bodyPr wrap="square" lIns="0" tIns="0" rIns="0" bIns="0" rtlCol="0" anchor="ctr"/>
+          <a:lstStyle/>
+          <a:p>
+            <a:pPr indent="0" marL="0">
+              <a:buNone/>
+            </a:pPr>
+            <a:r>
+              <a:rPr lang="en-US" sz="1150" b="1" dirty="0">
+                <a:solidFill>
+                  <a:srgbClr val="0F2D52"/>
+                </a:solidFill>
+                <a:latin typeface="Courier New" pitchFamily="34" charset="0"/>
+                <a:ea typeface="Courier New" pitchFamily="34" charset="-122"/>
+                <a:cs typeface="Courier New" pitchFamily="34" charset="-120"/>
+              </a:rPr>
+              <a:t>10 ~ &lt;40 %  </a:t>
+            </a:r>
+            <a:pPr indent="0" marL="0">
+              <a:buNone/>
+            </a:pPr>
+            <a:r>
+              <a:rPr lang="en-US" sz="1150" dirty="0">
+                <a:solidFill>
+                  <a:srgbClr val="1A2733"/>
+                </a:solidFill>
+                <a:latin typeface="Courier New" pitchFamily="34" charset="0"/>
+                <a:ea typeface="Courier New" pitchFamily="34" charset="-122"/>
+                <a:cs typeface="Courier New" pitchFamily="34" charset="-120"/>
+              </a:rPr>
+              <a:t> #8cffa0  </a:t>
+            </a:r>
+            <a:pPr indent="0" marL="0">
+              <a:buNone/>
+            </a:pPr>
+            <a:r>
+              <a:rPr lang="en-US" sz="1250" b="1" dirty="0">
+                <a:solidFill>
+                  <a:srgbClr val="1A2733"/>
+                </a:solidFill>
+              </a:rPr>
+              <a:t>성긴 유빙 1~3/10  </a:t>
+            </a:r>
+            <a:pPr indent="0" marL="0">
+              <a:buNone/>
+            </a:pPr>
+            <a:r>
+              <a:rPr lang="en-US" sz="1100" dirty="0">
+                <a:solidFill>
+                  <a:srgbClr val="6B7B8C"/>
+                </a:solidFill>
+              </a:rPr>
+              <a:t>Very open drift ice</a:t>
+            </a:r>
+            <a:endParaRPr lang="en-US" sz="1150" dirty="0"/>
+          </a:p>
+        </p:txBody>
+      </p:sp>
+      <p:sp>
+        <p:nvSpPr>
+          <p:cNvPr id="10" name="Shape 8"/>
+          <p:cNvSpPr/>
+          <p:nvPr/>
+        </p:nvSpPr>
+        <p:spPr>
+          <a:xfrm>
+            <a:off x="502920" y="2660904"/>
+            <a:ext cx="502920" cy="329184"/>
+          </a:xfrm>
+          <a:prstGeom prst="rect">
+            <a:avLst/>
+          </a:prstGeom>
+          <a:solidFill>
+            <a:srgbClr val="FFFF00"/>
+          </a:solidFill>
+          <a:ln w="9525">
+            <a:solidFill>
+              <a:srgbClr val="B9C4CE"/>
+            </a:solidFill>
+            <a:prstDash val="solid"/>
+          </a:ln>
+        </p:spPr>
+      </p:sp>
+      <p:sp>
+        <p:nvSpPr>
+          <p:cNvPr id="11" name="Text 9"/>
+          <p:cNvSpPr txBox="1"/>
+          <p:nvPr/>
+        </p:nvSpPr>
+        <p:spPr>
+          <a:xfrm>
+            <a:off x="1143000" y="2660904"/>
+            <a:ext cx="6400800" cy="329184"/>
+          </a:xfrm>
+          <a:prstGeom prst="rect">
+            <a:avLst/>
+          </a:prstGeom>
+          <a:noFill/>
+          <a:ln/>
+        </p:spPr>
+        <p:txBody>
+          <a:bodyPr wrap="square" lIns="0" tIns="0" rIns="0" bIns="0" rtlCol="0" anchor="ctr"/>
+          <a:lstStyle/>
+          <a:p>
+            <a:pPr indent="0" marL="0">
+              <a:buNone/>
+            </a:pPr>
+            <a:r>
+              <a:rPr lang="en-US" sz="1150" b="1" dirty="0">
+                <a:solidFill>
+                  <a:srgbClr val="0F2D52"/>
+                </a:solidFill>
+                <a:latin typeface="Courier New" pitchFamily="34" charset="0"/>
+                <a:ea typeface="Courier New" pitchFamily="34" charset="-122"/>
+                <a:cs typeface="Courier New" pitchFamily="34" charset="-120"/>
+              </a:rPr>
+              <a:t>40 ~ &lt;70 %  </a:t>
+            </a:r>
+            <a:pPr indent="0" marL="0">
+              <a:buNone/>
+            </a:pPr>
+            <a:r>
+              <a:rPr lang="en-US" sz="1150" dirty="0">
+                <a:solidFill>
+                  <a:srgbClr val="1A2733"/>
+                </a:solidFill>
+                <a:latin typeface="Courier New" pitchFamily="34" charset="0"/>
+                <a:ea typeface="Courier New" pitchFamily="34" charset="-122"/>
+                <a:cs typeface="Courier New" pitchFamily="34" charset="-120"/>
+              </a:rPr>
+              <a:t> #ffff00  </a:t>
+            </a:r>
+            <a:pPr indent="0" marL="0">
+              <a:buNone/>
+            </a:pPr>
+            <a:r>
+              <a:rPr lang="en-US" sz="1250" b="1" dirty="0">
+                <a:solidFill>
+                  <a:srgbClr val="1A2733"/>
+                </a:solidFill>
+              </a:rPr>
+              <a:t>산재 유빙 4~6/10  </a:t>
+            </a:r>
+            <a:pPr indent="0" marL="0">
+              <a:buNone/>
+            </a:pPr>
+            <a:r>
+              <a:rPr lang="en-US" sz="1100" dirty="0">
+                <a:solidFill>
+                  <a:srgbClr val="6B7B8C"/>
+                </a:solidFill>
+              </a:rPr>
+              <a:t>Open drift ice</a:t>
+            </a:r>
+            <a:endParaRPr lang="en-US" sz="1150" dirty="0"/>
+          </a:p>
+        </p:txBody>
+      </p:sp>
+      <p:sp>
+        <p:nvSpPr>
+          <p:cNvPr id="12" name="Shape 10"/>
+          <p:cNvSpPr/>
+          <p:nvPr/>
+        </p:nvSpPr>
+        <p:spPr>
+          <a:xfrm>
+            <a:off x="502920" y="3090672"/>
+            <a:ext cx="502920" cy="329184"/>
+          </a:xfrm>
+          <a:prstGeom prst="rect">
+            <a:avLst/>
+          </a:prstGeom>
+          <a:solidFill>
+            <a:srgbClr val="FF7D07"/>
+          </a:solidFill>
+          <a:ln w="9525">
+            <a:solidFill>
+              <a:srgbClr val="B9C4CE"/>
+            </a:solidFill>
+            <a:prstDash val="solid"/>
+          </a:ln>
+        </p:spPr>
+      </p:sp>
+      <p:sp>
+        <p:nvSpPr>
+          <p:cNvPr id="13" name="Text 11"/>
+          <p:cNvSpPr txBox="1"/>
+          <p:nvPr/>
+        </p:nvSpPr>
+        <p:spPr>
+          <a:xfrm>
+            <a:off x="1143000" y="3090672"/>
+            <a:ext cx="6400800" cy="329184"/>
+          </a:xfrm>
+          <a:prstGeom prst="rect">
+            <a:avLst/>
+          </a:prstGeom>
+          <a:noFill/>
+          <a:ln/>
+        </p:spPr>
+        <p:txBody>
+          <a:bodyPr wrap="square" lIns="0" tIns="0" rIns="0" bIns="0" rtlCol="0" anchor="ctr"/>
+          <a:lstStyle/>
+          <a:p>
+            <a:pPr indent="0" marL="0">
+              <a:buNone/>
+            </a:pPr>
+            <a:r>
+              <a:rPr lang="en-US" sz="1150" b="1" dirty="0">
+                <a:solidFill>
+                  <a:srgbClr val="0F2D52"/>
+                </a:solidFill>
+                <a:latin typeface="Courier New" pitchFamily="34" charset="0"/>
+                <a:ea typeface="Courier New" pitchFamily="34" charset="-122"/>
+                <a:cs typeface="Courier New" pitchFamily="34" charset="-120"/>
+              </a:rPr>
+              <a:t>70 ~ &lt;90 %  </a:t>
+            </a:r>
+            <a:pPr indent="0" marL="0">
+              <a:buNone/>
+            </a:pPr>
+            <a:r>
+              <a:rPr lang="en-US" sz="1150" dirty="0">
+                <a:solidFill>
+                  <a:srgbClr val="1A2733"/>
+                </a:solidFill>
+                <a:latin typeface="Courier New" pitchFamily="34" charset="0"/>
+                <a:ea typeface="Courier New" pitchFamily="34" charset="-122"/>
+                <a:cs typeface="Courier New" pitchFamily="34" charset="-120"/>
+              </a:rPr>
+              <a:t> #ff7d07  </a:t>
+            </a:r>
+            <a:pPr indent="0" marL="0">
+              <a:buNone/>
+            </a:pPr>
+            <a:r>
+              <a:rPr lang="en-US" sz="1250" b="1" dirty="0">
+                <a:solidFill>
+                  <a:srgbClr val="1A2733"/>
+                </a:solidFill>
+              </a:rPr>
+              <a:t>밀집 유빙 7~8/10  </a:t>
+            </a:r>
+            <a:pPr indent="0" marL="0">
+              <a:buNone/>
+            </a:pPr>
+            <a:r>
+              <a:rPr lang="en-US" sz="1100" dirty="0">
+                <a:solidFill>
+                  <a:srgbClr val="6B7B8C"/>
+                </a:solidFill>
+              </a:rPr>
+              <a:t>Close drift ice</a:t>
+            </a:r>
+            <a:endParaRPr lang="en-US" sz="1150" dirty="0"/>
+          </a:p>
+        </p:txBody>
+      </p:sp>
+      <p:sp>
+        <p:nvSpPr>
+          <p:cNvPr id="14" name="Shape 12"/>
+          <p:cNvSpPr/>
+          <p:nvPr/>
+        </p:nvSpPr>
+        <p:spPr>
+          <a:xfrm>
+            <a:off x="502920" y="3520440"/>
+            <a:ext cx="502920" cy="329184"/>
+          </a:xfrm>
+          <a:prstGeom prst="rect">
+            <a:avLst/>
+          </a:prstGeom>
+          <a:solidFill>
+            <a:srgbClr val="FF0000"/>
+          </a:solidFill>
+          <a:ln w="9525">
+            <a:solidFill>
+              <a:srgbClr val="B9C4CE"/>
+            </a:solidFill>
+            <a:prstDash val="solid"/>
+          </a:ln>
+        </p:spPr>
+      </p:sp>
+      <p:sp>
+        <p:nvSpPr>
+          <p:cNvPr id="15" name="Text 13"/>
+          <p:cNvSpPr txBox="1"/>
+          <p:nvPr/>
+        </p:nvSpPr>
+        <p:spPr>
+          <a:xfrm>
+            <a:off x="1143000" y="3520440"/>
+            <a:ext cx="6400800" cy="329184"/>
+          </a:xfrm>
+          <a:prstGeom prst="rect">
+            <a:avLst/>
+          </a:prstGeom>
+          <a:noFill/>
+          <a:ln/>
+        </p:spPr>
+        <p:txBody>
+          <a:bodyPr wrap="square" lIns="0" tIns="0" rIns="0" bIns="0" rtlCol="0" anchor="ctr"/>
+          <a:lstStyle/>
+          <a:p>
+            <a:pPr indent="0" marL="0">
+              <a:buNone/>
+            </a:pPr>
+            <a:r>
+              <a:rPr lang="en-US" sz="1150" b="1" dirty="0">
+                <a:solidFill>
+                  <a:srgbClr val="0F2D52"/>
+                </a:solidFill>
+                <a:latin typeface="Courier New" pitchFamily="34" charset="0"/>
+                <a:ea typeface="Courier New" pitchFamily="34" charset="-122"/>
+                <a:cs typeface="Courier New" pitchFamily="34" charset="-120"/>
+              </a:rPr>
+              <a:t>90 ~ 100 %  </a:t>
+            </a:r>
+            <a:pPr indent="0" marL="0">
+              <a:buNone/>
+            </a:pPr>
+            <a:r>
+              <a:rPr lang="en-US" sz="1150" dirty="0">
+                <a:solidFill>
+                  <a:srgbClr val="1A2733"/>
+                </a:solidFill>
+                <a:latin typeface="Courier New" pitchFamily="34" charset="0"/>
+                <a:ea typeface="Courier New" pitchFamily="34" charset="-122"/>
+                <a:cs typeface="Courier New" pitchFamily="34" charset="-120"/>
+              </a:rPr>
+              <a:t> #ff0000  </a:t>
+            </a:r>
+            <a:pPr indent="0" marL="0">
+              <a:buNone/>
+            </a:pPr>
+            <a:r>
+              <a:rPr lang="en-US" sz="1250" b="1" dirty="0">
+                <a:solidFill>
+                  <a:srgbClr val="1A2733"/>
+                </a:solidFill>
+              </a:rPr>
+              <a:t>초밀집 9~10/10  </a:t>
+            </a:r>
+            <a:pPr indent="0" marL="0">
+              <a:buNone/>
+            </a:pPr>
+            <a:r>
+              <a:rPr lang="en-US" sz="1100" dirty="0">
+                <a:solidFill>
+                  <a:srgbClr val="6B7B8C"/>
+                </a:solidFill>
+              </a:rPr>
+              <a:t>Very close drift ice</a:t>
+            </a:r>
+            <a:endParaRPr lang="en-US" sz="1150" dirty="0"/>
+          </a:p>
+        </p:txBody>
+      </p:sp>
+      <p:sp>
+        <p:nvSpPr>
+          <p:cNvPr id="16" name="Text 14"/>
+          <p:cNvSpPr txBox="1"/>
+          <p:nvPr/>
+        </p:nvSpPr>
+        <p:spPr>
+          <a:xfrm>
+            <a:off x="502920" y="4160520"/>
+            <a:ext cx="6949440" cy="2103120"/>
+          </a:xfrm>
+          <a:prstGeom prst="rect">
+            <a:avLst/>
+          </a:prstGeom>
+          <a:noFill/>
+          <a:ln/>
+        </p:spPr>
+        <p:txBody>
+          <a:bodyPr wrap="square" lIns="0" tIns="0" rIns="0" bIns="0" rtlCol="0" anchor="t"/>
+          <a:lstStyle/>
+          <a:p>
+            <a:pPr indent="0" marL="0">
+              <a:spcAft>
+                <a:spcPts val="600"/>
+              </a:spcAft>
+              <a:buNone/>
+            </a:pPr>
+            <a:r>
+              <a:rPr lang="en-US" sz="1400" b="1" dirty="0">
+                <a:solidFill>
+                  <a:srgbClr val="0F2D52"/>
+                </a:solidFill>
+              </a:rPr>
+              <a:t>사용 방법</a:t>
+            </a:r>
+            <a:endParaRPr lang="en-US" sz="1400" dirty="0"/>
+          </a:p>
+          <a:p>
+            <a:pPr marL="342900" indent="-342900">
+              <a:spcAft>
+                <a:spcPts val="500"/>
+              </a:spcAft>
+              <a:buSzPct val="100000"/>
+              <a:buChar char="•"/>
+            </a:pPr>
+            <a:r>
+              <a:rPr lang="en-US" sz="1200" dirty="0">
+                <a:solidFill>
+                  <a:srgbClr val="1A2733"/>
+                </a:solidFill>
+              </a:rPr>
+              <a:t>웹지도: 범례 패널 상단 [SIC 색상] 토글로 Rainbow 연속 &lt;-&gt; WMO 총빙량 전환 (그려진 SIC 레이어 즉시 다시 칠해지고, WMO 선택 시 범례가 계급 이름 목록으로 바뀜. 선택은 브라우저에 기억)</a:t>
+            </a:r>
+            <a:endParaRPr lang="en-US" sz="1400" dirty="0"/>
+          </a:p>
+          <a:p>
+            <a:pPr marL="342900" indent="-342900">
+              <a:spcAft>
+                <a:spcPts val="500"/>
+              </a:spcAft>
+              <a:buSzPct val="100000"/>
+              <a:buChar char="•"/>
+            </a:pPr>
+            <a:r>
+              <a:rPr lang="en-US" sz="1200" dirty="0">
+                <a:solidFill>
+                  <a:srgbClr val="1A2733"/>
+                </a:solidFill>
+              </a:rPr>
+              <a:t>PNG: 파이프라인이 두 가지를 동시 생산 — 기본 &lt;이름&gt;.png (rainbow) + &lt;이름&gt;_wmo.png (WMO 계급 + 범례 상자). 모델(polar_png 8모듈)·AMSR L2/L3·A25 합성 적용, GIF 애니메이션은 rainbow 프레임만 사용</a:t>
+            </a:r>
+            <a:endParaRPr lang="en-US" sz="1400" dirty="0"/>
+          </a:p>
+        </p:txBody>
+      </p:sp>
+      <p:pic>
+        <p:nvPicPr>
+          <p:cNvPr id="17" name="Image 0" descr="/home/claude/sicapply/wmo_legend.png">    </p:cNvPr>
+          <p:cNvPicPr>
+            <a:picLocks noChangeAspect="1"/>
+          </p:cNvPicPr>
+          <p:nvPr/>
+        </p:nvPicPr>
+        <p:blipFill>
+          <a:blip r:embed="rId1"/>
+          <a:stretch>
+            <a:fillRect/>
+          </a:stretch>
+        </p:blipFill>
+        <p:spPr>
+          <a:xfrm>
+            <a:off x="8229600" y="1554480"/>
+            <a:ext cx="3108960" cy="2157984"/>
+          </a:xfrm>
+          <a:prstGeom prst="rect">
+            <a:avLst/>
+          </a:prstGeom>
+        </p:spPr>
+      </p:pic>
+      <p:sp>
+        <p:nvSpPr>
+          <p:cNvPr id="18" name="Text 15"/>
+          <p:cNvSpPr txBox="1"/>
+          <p:nvPr/>
+        </p:nvSpPr>
+        <p:spPr>
+          <a:xfrm>
+            <a:off x="7863840" y="4069080"/>
+            <a:ext cx="3840480" cy="274320"/>
+          </a:xfrm>
+          <a:prstGeom prst="rect">
+            <a:avLst/>
+          </a:prstGeom>
+          <a:noFill/>
+          <a:ln/>
+        </p:spPr>
+        <p:txBody>
+          <a:bodyPr wrap="square" lIns="0" tIns="0" rIns="0" bIns="0" rtlCol="0" anchor="ctr"/>
+          <a:lstStyle/>
+          <a:p>
+            <a:pPr algn="ctr" indent="0" marL="0">
+              <a:buNone/>
+            </a:pPr>
+            <a:r>
+              <a:rPr lang="en-US" sz="1050" dirty="0">
+                <a:solidFill>
+                  <a:srgbClr val="6B7B8C"/>
+                </a:solidFill>
+              </a:rPr>
+              <a:t>PNG 에 삽입되는 WMO 범례 (좌하단, 영문 계급명)</a:t>
+            </a:r>
+            <a:endParaRPr lang="en-US" sz="1050" dirty="0"/>
+          </a:p>
+        </p:txBody>
+      </p:sp>
+      <p:sp>
+        <p:nvSpPr>
+          <p:cNvPr id="19" name="Shape 16"/>
+          <p:cNvSpPr/>
+          <p:nvPr/>
+        </p:nvSpPr>
+        <p:spPr>
+          <a:xfrm>
+            <a:off x="7863840" y="4526280"/>
+            <a:ext cx="3840480" cy="1737360"/>
+          </a:xfrm>
+          <a:prstGeom prst="roundRect">
+            <a:avLst>
+              <a:gd name="adj" fmla="val 4211"/>
+            </a:avLst>
+          </a:prstGeom>
+          <a:solidFill>
+            <a:srgbClr val="EAF2FA"/>
+          </a:solidFill>
+          <a:ln w="12700">
+            <a:solidFill>
+              <a:srgbClr val="0B6B5C"/>
+            </a:solidFill>
+            <a:prstDash val="solid"/>
+          </a:ln>
+        </p:spPr>
+      </p:sp>
+      <p:sp>
+        <p:nvSpPr>
+          <p:cNvPr id="20" name="Text 17"/>
+          <p:cNvSpPr txBox="1"/>
+          <p:nvPr/>
+        </p:nvSpPr>
+        <p:spPr>
+          <a:xfrm>
+            <a:off x="8092440" y="4663440"/>
+            <a:ext cx="3383280" cy="1508760"/>
+          </a:xfrm>
+          <a:prstGeom prst="rect">
+            <a:avLst/>
+          </a:prstGeom>
+          <a:noFill/>
+          <a:ln/>
+        </p:spPr>
+        <p:txBody>
+          <a:bodyPr wrap="square" lIns="0" tIns="0" rIns="0" bIns="0" rtlCol="0" anchor="t"/>
+          <a:lstStyle/>
+          <a:p>
+            <a:pPr indent="0" marL="0">
+              <a:spcAft>
+                <a:spcPts val="400"/>
+              </a:spcAft>
+              <a:buNone/>
+            </a:pPr>
+            <a:r>
+              <a:rPr lang="en-US" sz="1250" b="1" dirty="0">
+                <a:solidFill>
+                  <a:srgbClr val="0B6B5C"/>
+                </a:solidFill>
+              </a:rPr>
+              <a:t>선택 기준</a:t>
+            </a:r>
+            <a:endParaRPr lang="en-US" sz="1250" dirty="0"/>
+          </a:p>
+          <a:p>
+            <a:pPr marL="342900" indent="-342900">
+              <a:spcAft>
+                <a:spcPts val="300"/>
+              </a:spcAft>
+              <a:buSzPct val="100000"/>
+              <a:buChar char="•"/>
+            </a:pPr>
+            <a:r>
+              <a:rPr lang="en-US" sz="1150" dirty="0">
+                <a:solidFill>
+                  <a:srgbClr val="1A2733"/>
+                </a:solidFill>
+              </a:rPr>
+              <a:t>분석·세부 구조 확인 → Rainbow 연속</a:t>
+            </a:r>
+            <a:endParaRPr lang="en-US" sz="1250" dirty="0"/>
+          </a:p>
+          <a:p>
+            <a:pPr marL="342900" indent="-342900">
+              <a:buSzPct val="100000"/>
+              <a:buChar char="•"/>
+            </a:pPr>
+            <a:r>
+              <a:rPr lang="en-US" sz="1150" dirty="0">
+                <a:solidFill>
+                  <a:srgbClr val="1A2733"/>
+                </a:solidFill>
+              </a:rPr>
+              <a:t>보고서·대외 제공·운항 판단 → WMO 계급 (국제 표준 근거)</a:t>
+            </a:r>
+            <a:endParaRPr lang="en-US" sz="1250" dirty="0"/>
+          </a:p>
+        </p:txBody>
+      </p:sp>
+      <p:sp>
+        <p:nvSpPr>
+          <p:cNvPr id="25" name="Slide Number Placeholder 0"/>
+          <p:cNvSpPr>
+            <a:spLocks noGrp="1"/>
+          </p:cNvSpPr>
+          <p:nvPr>
+            <p:ph type="sldNum" sz="quarter" idx="4294967295"/>
+          </p:nvPr>
+        </p:nvSpPr>
+        <p:spPr>
+          <a:xfrm>
+            <a:off x="11430000" y="6510528"/>
+            <a:ext cx="548640" cy="274320"/>
+          </a:xfrm>
+          <a:prstGeom prst="rect">
+            <a:avLst/>
+          </a:prstGeom>
+          <a:extLst>
+            <a:ext uri="{C572A759-6A51-4108-AA02-DFA0A04FC94B}">
+              <ma14:wrappingTextBoxFlag xmlns:ma14="http://schemas.microsoft.com/office/mac/drawingml/2011/main" val="0"/>
+            </a:ext>
+          </a:extLst>
+        </p:spPr>
+        <p:txBody>
+          <a:bodyPr/>
+          <a:lstStyle>
+            <a:lvl1pPr>
+              <a:defRPr sz="900">
+                <a:solidFill>
+                  <a:srgbClr val="6B7B8C"/>
+                </a:solidFill>
+              </a:defRPr>
+            </a:lvl1pPr>
+          </a:lstStyle>
+          <a:p>
+            <a:pPr algn="l"/>
+            <a:fld id="{F7021451-1387-4CA6-816F-3879F97B5CBC}" type="slidenum">
+              <a:rPr b="0" lang="en-US"/>
+              <a:t>4</a:t>
             </a:fld>
             <a:endParaRPr lang="en-US"/>
           </a:p>

</xml_diff>